<commit_message>
Added maroon Color Accent version
</commit_message>
<xml_diff>
--- a/deck/ai-driven-development.pptx
+++ b/deck/ai-driven-development.pptx
@@ -170,7 +170,7 @@
     </p:spTree>
     <p:extLst>
       <p:ext uri="{BB962C8B-B14F-4D97-AF65-F5344CB8AC3E}">
-        <p14:creationId xmlns:p14="http://schemas.microsoft.com/office/powerpoint/2010/main" val="1946881467"/>
+        <p14:creationId xmlns:p14="http://schemas.microsoft.com/office/powerpoint/2010/main" val="719980036"/>
       </p:ext>
     </p:extLst>
   </p:cSld>
@@ -4660,7 +4660,7 @@
             <a:avLst/>
           </a:prstGeom>
           <a:solidFill>
-            <a:srgbClr val="0E4B48"/>
+            <a:srgbClr val="751F35"/>
           </a:solidFill>
           <a:ln>
             <a:noFill/>
@@ -4802,9 +4802,9 @@
               </a:spcAft>
             </a:pPr>
             <a:r>
-              <a:rPr sz="1400" b="1" i="0">
-                <a:solidFill>
-                  <a:srgbClr val="0E4B48"/>
+              <a:rPr lang="en-ZA" sz="1400" b="1" i="0">
+                <a:solidFill>
+                  <a:srgbClr val="751F35"/>
                 </a:solidFill>
                 <a:latin typeface="Calibri"/>
                 <a:ea typeface="Calibri"/>
@@ -4917,7 +4917,7 @@
             </a:avLst>
           </a:prstGeom>
           <a:solidFill>
-            <a:srgbClr val="E4F0EE"/>
+            <a:srgbClr val="F1E3E7"/>
           </a:solidFill>
           <a:ln>
             <a:noFill/>
@@ -4992,9 +4992,9 @@
               </a:spcAft>
             </a:pPr>
             <a:r>
-              <a:rPr sz="1600" b="1" i="0">
-                <a:solidFill>
-                  <a:srgbClr val="0E4B48"/>
+              <a:rPr lang="en-ZA" sz="1600" b="1" i="0">
+                <a:solidFill>
+                  <a:srgbClr val="751F35"/>
                 </a:solidFill>
                 <a:latin typeface="Calibri"/>
                 <a:ea typeface="Calibri"/>
@@ -5022,7 +5022,7 @@
             </a:avLst>
           </a:prstGeom>
           <a:solidFill>
-            <a:srgbClr val="E4F0EE"/>
+            <a:srgbClr val="F1E3E7"/>
           </a:solidFill>
           <a:ln>
             <a:noFill/>
@@ -5097,9 +5097,9 @@
               </a:spcAft>
             </a:pPr>
             <a:r>
-              <a:rPr sz="1600" b="1" i="0">
-                <a:solidFill>
-                  <a:srgbClr val="0E4B48"/>
+              <a:rPr lang="en-ZA" sz="1600" b="1" i="0">
+                <a:solidFill>
+                  <a:srgbClr val="751F35"/>
                 </a:solidFill>
                 <a:latin typeface="Calibri"/>
                 <a:ea typeface="Calibri"/>
@@ -5127,7 +5127,7 @@
             </a:avLst>
           </a:prstGeom>
           <a:solidFill>
-            <a:srgbClr val="E4F0EE"/>
+            <a:srgbClr val="F1E3E7"/>
           </a:solidFill>
           <a:ln>
             <a:noFill/>
@@ -5202,9 +5202,9 @@
               </a:spcAft>
             </a:pPr>
             <a:r>
-              <a:rPr sz="1600" b="1" i="0">
-                <a:solidFill>
-                  <a:srgbClr val="0E4B48"/>
+              <a:rPr lang="en-ZA" sz="1600" b="1" i="0">
+                <a:solidFill>
+                  <a:srgbClr val="751F35"/>
                 </a:solidFill>
                 <a:latin typeface="Calibri"/>
                 <a:ea typeface="Calibri"/>
@@ -5232,7 +5232,7 @@
             </a:avLst>
           </a:prstGeom>
           <a:solidFill>
-            <a:srgbClr val="0E4B48"/>
+            <a:srgbClr val="751F35"/>
           </a:solidFill>
           <a:ln>
             <a:noFill/>
@@ -5368,7 +5368,7 @@
             <a:avLst/>
           </a:prstGeom>
           <a:solidFill>
-            <a:srgbClr val="0E4B48"/>
+            <a:srgbClr val="751F35"/>
           </a:solidFill>
           <a:ln>
             <a:noFill/>
@@ -5510,9 +5510,9 @@
               </a:spcAft>
             </a:pPr>
             <a:r>
-              <a:rPr sz="1300" b="1" i="0">
-                <a:solidFill>
-                  <a:srgbClr val="0E4B48"/>
+              <a:rPr lang="en-ZA" sz="1300" b="1" i="0">
+                <a:solidFill>
+                  <a:srgbClr val="751F35"/>
                 </a:solidFill>
                 <a:latin typeface="Calibri"/>
                 <a:ea typeface="Calibri"/>
@@ -5617,9 +5617,9 @@
               </a:spcAft>
             </a:pPr>
             <a:r>
-              <a:rPr sz="1800" b="1" i="0">
-                <a:solidFill>
-                  <a:srgbClr val="0E4B48"/>
+              <a:rPr lang="en-ZA" sz="1800" b="1" i="0">
+                <a:solidFill>
+                  <a:srgbClr val="751F35"/>
                 </a:solidFill>
                 <a:latin typeface="Calibri"/>
                 <a:ea typeface="Calibri"/>
@@ -5850,9 +5850,9 @@
               </a:spcAft>
             </a:pPr>
             <a:r>
-              <a:rPr sz="1800" b="1" i="0">
-                <a:solidFill>
-                  <a:srgbClr val="0E4B48"/>
+              <a:rPr lang="en-ZA" sz="1800" b="1" i="0">
+                <a:solidFill>
+                  <a:srgbClr val="751F35"/>
                 </a:solidFill>
                 <a:latin typeface="Calibri"/>
                 <a:ea typeface="Calibri"/>
@@ -6083,9 +6083,9 @@
               </a:spcAft>
             </a:pPr>
             <a:r>
-              <a:rPr sz="1800" b="1" i="0">
-                <a:solidFill>
-                  <a:srgbClr val="0E4B48"/>
+              <a:rPr lang="en-ZA" sz="1800" b="1" i="0">
+                <a:solidFill>
+                  <a:srgbClr val="751F35"/>
                 </a:solidFill>
                 <a:latin typeface="Calibri"/>
                 <a:ea typeface="Calibri"/>
@@ -6316,9 +6316,9 @@
               </a:spcAft>
             </a:pPr>
             <a:r>
-              <a:rPr sz="1800" b="1" i="0">
-                <a:solidFill>
-                  <a:srgbClr val="0E4B48"/>
+              <a:rPr lang="en-ZA" sz="1800" b="1" i="0">
+                <a:solidFill>
+                  <a:srgbClr val="751F35"/>
                 </a:solidFill>
                 <a:latin typeface="Calibri"/>
                 <a:ea typeface="Calibri"/>
@@ -6526,9 +6526,9 @@
               </a:spcAft>
             </a:pPr>
             <a:r>
-              <a:rPr sz="1800" b="1" i="0">
-                <a:solidFill>
-                  <a:srgbClr val="0E4B48"/>
+              <a:rPr lang="en-ZA" sz="1800" b="1" i="0">
+                <a:solidFill>
+                  <a:srgbClr val="751F35"/>
                 </a:solidFill>
                 <a:latin typeface="Calibri"/>
                 <a:ea typeface="Calibri"/>
@@ -6587,7 +6587,7 @@
             <a:avLst/>
           </a:prstGeom>
           <a:solidFill>
-            <a:srgbClr val="0E4B48"/>
+            <a:srgbClr val="751F35"/>
           </a:solidFill>
           <a:ln>
             <a:noFill/>
@@ -6729,9 +6729,9 @@
               </a:spcAft>
             </a:pPr>
             <a:r>
-              <a:rPr sz="1300" b="1" i="0">
-                <a:solidFill>
-                  <a:srgbClr val="0E4B48"/>
+              <a:rPr lang="en-ZA" sz="1300" b="1" i="0">
+                <a:solidFill>
+                  <a:srgbClr val="751F35"/>
                 </a:solidFill>
                 <a:latin typeface="Calibri"/>
                 <a:ea typeface="Calibri"/>
@@ -6799,7 +6799,7 @@
             <a:avLst/>
           </a:prstGeom>
           <a:solidFill>
-            <a:srgbClr val="0E4B48"/>
+            <a:srgbClr val="751F35"/>
           </a:solidFill>
           <a:ln>
             <a:noFill/>
@@ -6923,7 +6923,7 @@
             <a:avLst/>
           </a:prstGeom>
           <a:solidFill>
-            <a:srgbClr val="0E4B48"/>
+            <a:srgbClr val="751F35"/>
           </a:solidFill>
           <a:ln>
             <a:noFill/>
@@ -7047,7 +7047,7 @@
             <a:avLst/>
           </a:prstGeom>
           <a:solidFill>
-            <a:srgbClr val="0E4B48"/>
+            <a:srgbClr val="751F35"/>
           </a:solidFill>
           <a:ln>
             <a:noFill/>
@@ -7204,7 +7204,7 @@
             <a:avLst/>
           </a:prstGeom>
           <a:solidFill>
-            <a:srgbClr val="0E4B48"/>
+            <a:srgbClr val="751F35"/>
           </a:solidFill>
           <a:ln>
             <a:noFill/>
@@ -7346,9 +7346,9 @@
               </a:spcAft>
             </a:pPr>
             <a:r>
-              <a:rPr sz="1300" b="1" i="0">
-                <a:solidFill>
-                  <a:srgbClr val="0E4B48"/>
+              <a:rPr lang="en-ZA" sz="1300" b="1" i="0">
+                <a:solidFill>
+                  <a:srgbClr val="751F35"/>
                 </a:solidFill>
                 <a:latin typeface="Calibri"/>
                 <a:ea typeface="Calibri"/>
@@ -7418,7 +7418,7 @@
             </a:avLst>
           </a:prstGeom>
           <a:solidFill>
-            <a:srgbClr val="0E4B48"/>
+            <a:srgbClr val="751F35"/>
           </a:solidFill>
           <a:ln>
             <a:noFill/>
@@ -7451,9 +7451,9 @@
               </a:spcAft>
             </a:pPr>
             <a:r>
-              <a:rPr sz="1400" b="1" i="0">
-                <a:solidFill>
-                  <a:srgbClr val="E4F0EE"/>
+              <a:rPr lang="en-ZA" sz="1400" b="1" i="0">
+                <a:solidFill>
+                  <a:srgbClr val="F1E3E7"/>
                 </a:solidFill>
                 <a:latin typeface="Calibri"/>
                 <a:ea typeface="Calibri"/>
@@ -7558,9 +7558,9 @@
               </a:spcAft>
             </a:pPr>
             <a:r>
-              <a:rPr sz="1400" b="1" i="0">
-                <a:solidFill>
-                  <a:srgbClr val="0E4B48"/>
+              <a:rPr lang="en-ZA" sz="1400" b="1" i="0">
+                <a:solidFill>
+                  <a:srgbClr val="751F35"/>
                 </a:solidFill>
                 <a:latin typeface="Calibri"/>
                 <a:ea typeface="Calibri"/>
@@ -7661,7 +7661,7 @@
             <a:avLst/>
           </a:prstGeom>
           <a:solidFill>
-            <a:srgbClr val="0E4B48"/>
+            <a:srgbClr val="751F35"/>
           </a:solidFill>
           <a:ln>
             <a:noFill/>
@@ -7803,9 +7803,9 @@
               </a:spcAft>
             </a:pPr>
             <a:r>
-              <a:rPr sz="1300" b="1" i="0">
-                <a:solidFill>
-                  <a:srgbClr val="0E4B48"/>
+              <a:rPr lang="en-ZA" sz="1300" b="1" i="0">
+                <a:solidFill>
+                  <a:srgbClr val="751F35"/>
                 </a:solidFill>
                 <a:latin typeface="Calibri"/>
                 <a:ea typeface="Calibri"/>
@@ -7875,7 +7875,7 @@
             </a:avLst>
           </a:prstGeom>
           <a:solidFill>
-            <a:srgbClr val="0E4B48"/>
+            <a:srgbClr val="751F35"/>
           </a:solidFill>
           <a:ln>
             <a:noFill/>
@@ -8005,7 +8005,7 @@
             </a:avLst>
           </a:prstGeom>
           <a:solidFill>
-            <a:srgbClr val="0E4B48"/>
+            <a:srgbClr val="751F35"/>
           </a:solidFill>
           <a:ln>
             <a:noFill/>
@@ -8135,7 +8135,7 @@
             </a:avLst>
           </a:prstGeom>
           <a:solidFill>
-            <a:srgbClr val="0E4B48"/>
+            <a:srgbClr val="751F35"/>
           </a:solidFill>
           <a:ln>
             <a:noFill/>
@@ -8338,7 +8338,7 @@
             <a:avLst/>
           </a:prstGeom>
           <a:solidFill>
-            <a:srgbClr val="0E4B48"/>
+            <a:srgbClr val="751F35"/>
           </a:solidFill>
           <a:ln>
             <a:noFill/>
@@ -8480,9 +8480,9 @@
               </a:spcAft>
             </a:pPr>
             <a:r>
-              <a:rPr sz="1300" b="1" i="0">
-                <a:solidFill>
-                  <a:srgbClr val="0E4B48"/>
+              <a:rPr lang="en-ZA" sz="1300" b="1" i="0">
+                <a:solidFill>
+                  <a:srgbClr val="751F35"/>
                 </a:solidFill>
                 <a:latin typeface="Calibri"/>
                 <a:ea typeface="Calibri"/>
@@ -8552,7 +8552,7 @@
             </a:avLst>
           </a:prstGeom>
           <a:solidFill>
-            <a:srgbClr val="E4F0EE"/>
+            <a:srgbClr val="F1E3E7"/>
           </a:solidFill>
           <a:ln>
             <a:noFill/>
@@ -8627,9 +8627,9 @@
               </a:spcAft>
             </a:pPr>
             <a:r>
-              <a:rPr sz="1600" b="1" i="0">
-                <a:solidFill>
-                  <a:srgbClr val="0E4B48"/>
+              <a:rPr lang="en-ZA" sz="1600" b="1" i="0">
+                <a:solidFill>
+                  <a:srgbClr val="751F35"/>
                 </a:solidFill>
                 <a:latin typeface="Calibri"/>
                 <a:ea typeface="Calibri"/>
@@ -8657,7 +8657,7 @@
             </a:avLst>
           </a:prstGeom>
           <a:solidFill>
-            <a:srgbClr val="E4F0EE"/>
+            <a:srgbClr val="F1E3E7"/>
           </a:solidFill>
           <a:ln>
             <a:noFill/>
@@ -8732,9 +8732,9 @@
               </a:spcAft>
             </a:pPr>
             <a:r>
-              <a:rPr sz="1600" b="1" i="0">
-                <a:solidFill>
-                  <a:srgbClr val="0E4B48"/>
+              <a:rPr lang="en-ZA" sz="1600" b="1" i="0">
+                <a:solidFill>
+                  <a:srgbClr val="751F35"/>
                 </a:solidFill>
                 <a:latin typeface="Calibri"/>
                 <a:ea typeface="Calibri"/>
@@ -8762,7 +8762,7 @@
             </a:avLst>
           </a:prstGeom>
           <a:solidFill>
-            <a:srgbClr val="E4F0EE"/>
+            <a:srgbClr val="F1E3E7"/>
           </a:solidFill>
           <a:ln>
             <a:noFill/>
@@ -8837,9 +8837,9 @@
               </a:spcAft>
             </a:pPr>
             <a:r>
-              <a:rPr sz="1600" b="1" i="0">
-                <a:solidFill>
-                  <a:srgbClr val="0E4B48"/>
+              <a:rPr lang="en-ZA" sz="1600" b="1" i="0">
+                <a:solidFill>
+                  <a:srgbClr val="751F35"/>
                 </a:solidFill>
                 <a:latin typeface="Calibri"/>
                 <a:ea typeface="Calibri"/>
@@ -8867,7 +8867,7 @@
             </a:avLst>
           </a:prstGeom>
           <a:solidFill>
-            <a:srgbClr val="E4F0EE"/>
+            <a:srgbClr val="F1E3E7"/>
           </a:solidFill>
           <a:ln>
             <a:noFill/>
@@ -8942,9 +8942,9 @@
               </a:spcAft>
             </a:pPr>
             <a:r>
-              <a:rPr sz="1600" b="1" i="0">
-                <a:solidFill>
-                  <a:srgbClr val="0E4B48"/>
+              <a:rPr lang="en-ZA" sz="1600" b="1" i="0">
+                <a:solidFill>
+                  <a:srgbClr val="751F35"/>
                 </a:solidFill>
                 <a:latin typeface="Calibri"/>
                 <a:ea typeface="Calibri"/>
@@ -8972,7 +8972,7 @@
             </a:avLst>
           </a:prstGeom>
           <a:solidFill>
-            <a:srgbClr val="0E4B48"/>
+            <a:srgbClr val="751F35"/>
           </a:solidFill>
           <a:ln>
             <a:noFill/>
@@ -9070,9 +9070,9 @@
               </a:spcAft>
             </a:pPr>
             <a:r>
-              <a:rPr sz="2200" b="1" i="0">
-                <a:solidFill>
-                  <a:srgbClr val="0E4B48"/>
+              <a:rPr lang="en-ZA" sz="2200" b="1" i="0">
+                <a:solidFill>
+                  <a:srgbClr val="751F35"/>
                 </a:solidFill>
                 <a:latin typeface="Calibri"/>
                 <a:ea typeface="Calibri"/>
@@ -9156,9 +9156,9 @@
               </a:spcAft>
             </a:pPr>
             <a:r>
-              <a:rPr sz="2200" b="1" i="0">
-                <a:solidFill>
-                  <a:srgbClr val="0E4B48"/>
+              <a:rPr lang="en-ZA" sz="2200" b="1" i="0">
+                <a:solidFill>
+                  <a:srgbClr val="751F35"/>
                 </a:solidFill>
                 <a:latin typeface="Calibri"/>
                 <a:ea typeface="Calibri"/>
@@ -9242,9 +9242,9 @@
               </a:spcAft>
             </a:pPr>
             <a:r>
-              <a:rPr sz="2200" b="1" i="0">
-                <a:solidFill>
-                  <a:srgbClr val="0E4B48"/>
+              <a:rPr lang="en-ZA" sz="2200" b="1" i="0">
+                <a:solidFill>
+                  <a:srgbClr val="751F35"/>
                 </a:solidFill>
                 <a:latin typeface="Calibri"/>
                 <a:ea typeface="Calibri"/>
@@ -9324,7 +9324,7 @@
             <a:avLst/>
           </a:prstGeom>
           <a:solidFill>
-            <a:srgbClr val="0E4B48"/>
+            <a:srgbClr val="751F35"/>
           </a:solidFill>
           <a:ln>
             <a:noFill/>
@@ -9466,9 +9466,9 @@
               </a:spcAft>
             </a:pPr>
             <a:r>
-              <a:rPr sz="1300" b="1" i="0">
-                <a:solidFill>
-                  <a:srgbClr val="0E4B48"/>
+              <a:rPr lang="en-ZA" sz="1300" b="1" i="0">
+                <a:solidFill>
+                  <a:srgbClr val="751F35"/>
                 </a:solidFill>
                 <a:latin typeface="Calibri"/>
                 <a:ea typeface="Calibri"/>
@@ -9573,9 +9573,9 @@
               </a:spcAft>
             </a:pPr>
             <a:r>
-              <a:rPr sz="1400" b="1" i="0">
-                <a:solidFill>
-                  <a:srgbClr val="0E4B48"/>
+              <a:rPr lang="en-ZA" sz="1400" b="1" i="0">
+                <a:solidFill>
+                  <a:srgbClr val="751F35"/>
                 </a:solidFill>
                 <a:latin typeface="Calibri"/>
                 <a:ea typeface="Calibri"/>
@@ -9645,7 +9645,7 @@
             </a:avLst>
           </a:prstGeom>
           <a:solidFill>
-            <a:srgbClr val="0E4B48"/>
+            <a:srgbClr val="751F35"/>
           </a:solidFill>
           <a:ln>
             <a:noFill/>
@@ -9678,9 +9678,9 @@
               </a:spcAft>
             </a:pPr>
             <a:r>
-              <a:rPr sz="1400" b="1" i="0">
-                <a:solidFill>
-                  <a:srgbClr val="E4F0EE"/>
+              <a:rPr lang="en-ZA" sz="1400" b="1" i="0">
+                <a:solidFill>
+                  <a:srgbClr val="F1E3E7"/>
                 </a:solidFill>
                 <a:latin typeface="Calibri"/>
                 <a:ea typeface="Calibri"/>
@@ -9781,7 +9781,7 @@
             <a:avLst/>
           </a:prstGeom>
           <a:solidFill>
-            <a:srgbClr val="0E4B48"/>
+            <a:srgbClr val="751F35"/>
           </a:solidFill>
           <a:ln>
             <a:noFill/>
@@ -9923,9 +9923,9 @@
               </a:spcAft>
             </a:pPr>
             <a:r>
-              <a:rPr sz="1300" b="1" i="0">
-                <a:solidFill>
-                  <a:srgbClr val="0E4B48"/>
+              <a:rPr lang="en-ZA" sz="1300" b="1" i="0">
+                <a:solidFill>
+                  <a:srgbClr val="751F35"/>
                 </a:solidFill>
                 <a:latin typeface="Calibri"/>
                 <a:ea typeface="Calibri"/>
@@ -10038,7 +10038,7 @@
             </a:avLst>
           </a:prstGeom>
           <a:solidFill>
-            <a:srgbClr val="E4F0EE"/>
+            <a:srgbClr val="F1E3E7"/>
           </a:solidFill>
           <a:ln>
             <a:noFill/>
@@ -10113,9 +10113,9 @@
               </a:spcAft>
             </a:pPr>
             <a:r>
-              <a:rPr sz="1600" b="1" i="0">
-                <a:solidFill>
-                  <a:srgbClr val="0E4B48"/>
+              <a:rPr lang="en-ZA" sz="1600" b="1" i="0">
+                <a:solidFill>
+                  <a:srgbClr val="751F35"/>
                 </a:solidFill>
                 <a:latin typeface="Calibri"/>
                 <a:ea typeface="Calibri"/>
@@ -10143,7 +10143,7 @@
             </a:avLst>
           </a:prstGeom>
           <a:solidFill>
-            <a:srgbClr val="E4F0EE"/>
+            <a:srgbClr val="F1E3E7"/>
           </a:solidFill>
           <a:ln>
             <a:noFill/>
@@ -10218,9 +10218,9 @@
               </a:spcAft>
             </a:pPr>
             <a:r>
-              <a:rPr sz="1600" b="1" i="0">
-                <a:solidFill>
-                  <a:srgbClr val="0E4B48"/>
+              <a:rPr lang="en-ZA" sz="1600" b="1" i="0">
+                <a:solidFill>
+                  <a:srgbClr val="751F35"/>
                 </a:solidFill>
                 <a:latin typeface="Calibri"/>
                 <a:ea typeface="Calibri"/>
@@ -10248,7 +10248,7 @@
             </a:avLst>
           </a:prstGeom>
           <a:solidFill>
-            <a:srgbClr val="0E4B48"/>
+            <a:srgbClr val="751F35"/>
           </a:solidFill>
           <a:ln>
             <a:noFill/>
@@ -10384,7 +10384,7 @@
             <a:avLst/>
           </a:prstGeom>
           <a:solidFill>
-            <a:srgbClr val="0E4B48"/>
+            <a:srgbClr val="751F35"/>
           </a:solidFill>
           <a:ln>
             <a:noFill/>
@@ -10526,9 +10526,9 @@
               </a:spcAft>
             </a:pPr>
             <a:r>
-              <a:rPr sz="1300" b="1" i="0">
-                <a:solidFill>
-                  <a:srgbClr val="0E4B48"/>
+              <a:rPr lang="en-ZA" sz="1300" b="1" i="0">
+                <a:solidFill>
+                  <a:srgbClr val="751F35"/>
                 </a:solidFill>
                 <a:latin typeface="Calibri"/>
                 <a:ea typeface="Calibri"/>
@@ -10598,7 +10598,7 @@
             </a:avLst>
           </a:prstGeom>
           <a:solidFill>
-            <a:srgbClr val="0E4B48"/>
+            <a:srgbClr val="751F35"/>
           </a:solidFill>
           <a:ln>
             <a:noFill/>
@@ -10631,9 +10631,9 @@
               </a:spcAft>
             </a:pPr>
             <a:r>
-              <a:rPr sz="1400" b="1" i="0">
-                <a:solidFill>
-                  <a:srgbClr val="E4F0EE"/>
+              <a:rPr lang="en-ZA" sz="1400" b="1" i="0">
+                <a:solidFill>
+                  <a:srgbClr val="F1E3E7"/>
                 </a:solidFill>
                 <a:latin typeface="Calibri"/>
                 <a:ea typeface="Calibri"/>
@@ -10738,9 +10738,9 @@
               </a:spcAft>
             </a:pPr>
             <a:r>
-              <a:rPr sz="1400" b="1" i="0">
-                <a:solidFill>
-                  <a:srgbClr val="0E4B48"/>
+              <a:rPr lang="en-ZA" sz="1400" b="1" i="0">
+                <a:solidFill>
+                  <a:srgbClr val="751F35"/>
                 </a:solidFill>
                 <a:latin typeface="Calibri"/>
                 <a:ea typeface="Calibri"/>
@@ -10841,7 +10841,7 @@
             <a:avLst/>
           </a:prstGeom>
           <a:solidFill>
-            <a:srgbClr val="0E4B48"/>
+            <a:srgbClr val="751F35"/>
           </a:solidFill>
           <a:ln>
             <a:noFill/>
@@ -10983,9 +10983,9 @@
               </a:spcAft>
             </a:pPr>
             <a:r>
-              <a:rPr sz="1300" b="1" i="0">
-                <a:solidFill>
-                  <a:srgbClr val="0E4B48"/>
+              <a:rPr lang="en-ZA" sz="1300" b="1" i="0">
+                <a:solidFill>
+                  <a:srgbClr val="751F35"/>
                 </a:solidFill>
                 <a:latin typeface="Calibri"/>
                 <a:ea typeface="Calibri"/>
@@ -11097,7 +11097,7 @@
             </a:avLst>
           </a:prstGeom>
           <a:solidFill>
-            <a:srgbClr val="E4F0EE"/>
+            <a:srgbClr val="F1E3E7"/>
           </a:solidFill>
           <a:ln>
             <a:noFill/>
@@ -11172,9 +11172,9 @@
               </a:spcAft>
             </a:pPr>
             <a:r>
-              <a:rPr sz="1600" b="1" i="0">
-                <a:solidFill>
-                  <a:srgbClr val="0E4B48"/>
+              <a:rPr lang="en-ZA" sz="1600" b="1" i="0">
+                <a:solidFill>
+                  <a:srgbClr val="751F35"/>
                 </a:solidFill>
                 <a:latin typeface="Calibri"/>
                 <a:ea typeface="Calibri"/>
@@ -11202,7 +11202,7 @@
             </a:avLst>
           </a:prstGeom>
           <a:solidFill>
-            <a:srgbClr val="E4F0EE"/>
+            <a:srgbClr val="F1E3E7"/>
           </a:solidFill>
           <a:ln>
             <a:noFill/>
@@ -11277,9 +11277,9 @@
               </a:spcAft>
             </a:pPr>
             <a:r>
-              <a:rPr sz="1600" b="1" i="0">
-                <a:solidFill>
-                  <a:srgbClr val="0E4B48"/>
+              <a:rPr lang="en-ZA" sz="1600" b="1" i="0">
+                <a:solidFill>
+                  <a:srgbClr val="751F35"/>
                 </a:solidFill>
                 <a:latin typeface="Calibri"/>
                 <a:ea typeface="Calibri"/>
@@ -11307,7 +11307,7 @@
             </a:avLst>
           </a:prstGeom>
           <a:solidFill>
-            <a:srgbClr val="0E4B48"/>
+            <a:srgbClr val="751F35"/>
           </a:solidFill>
           <a:ln>
             <a:noFill/>
@@ -11443,7 +11443,7 @@
             <a:avLst/>
           </a:prstGeom>
           <a:solidFill>
-            <a:srgbClr val="0E4B48"/>
+            <a:srgbClr val="751F35"/>
           </a:solidFill>
           <a:ln>
             <a:noFill/>
@@ -11585,9 +11585,9 @@
               </a:spcAft>
             </a:pPr>
             <a:r>
-              <a:rPr sz="1300" b="1" i="0">
-                <a:solidFill>
-                  <a:srgbClr val="0E4B48"/>
+              <a:rPr lang="en-ZA" sz="1300" b="1" i="0">
+                <a:solidFill>
+                  <a:srgbClr val="751F35"/>
                 </a:solidFill>
                 <a:latin typeface="Calibri"/>
                 <a:ea typeface="Calibri"/>
@@ -11669,9 +11669,9 @@
               </a:spcAft>
             </a:pPr>
             <a:r>
-              <a:rPr sz="1600" b="1" i="0">
-                <a:solidFill>
-                  <a:srgbClr val="0E4B48"/>
+              <a:rPr lang="en-ZA" sz="1600" b="1" i="0">
+                <a:solidFill>
+                  <a:srgbClr val="751F35"/>
                 </a:solidFill>
                 <a:latin typeface="Calibri"/>
                 <a:ea typeface="Calibri"/>
@@ -11816,9 +11816,9 @@
               </a:spcAft>
             </a:pPr>
             <a:r>
-              <a:rPr sz="1600" b="1" i="0">
-                <a:solidFill>
-                  <a:srgbClr val="0E4B48"/>
+              <a:rPr lang="en-ZA" sz="1600" b="1" i="0">
+                <a:solidFill>
+                  <a:srgbClr val="751F35"/>
                 </a:solidFill>
                 <a:latin typeface="Calibri"/>
                 <a:ea typeface="Calibri"/>
@@ -11942,9 +11942,9 @@
               </a:spcAft>
             </a:pPr>
             <a:r>
-              <a:rPr sz="1600" b="1" i="0">
-                <a:solidFill>
-                  <a:srgbClr val="0E4B48"/>
+              <a:rPr lang="en-ZA" sz="1600" b="1" i="0">
+                <a:solidFill>
+                  <a:srgbClr val="751F35"/>
                 </a:solidFill>
                 <a:latin typeface="Calibri"/>
                 <a:ea typeface="Calibri"/>
@@ -12150,7 +12150,7 @@
             <a:avLst/>
           </a:prstGeom>
           <a:solidFill>
-            <a:srgbClr val="0E4B48"/>
+            <a:srgbClr val="751F35"/>
           </a:solidFill>
           <a:ln>
             <a:noFill/>
@@ -12292,9 +12292,9 @@
               </a:spcAft>
             </a:pPr>
             <a:r>
-              <a:rPr sz="1300" b="1" i="0">
-                <a:solidFill>
-                  <a:srgbClr val="0E4B48"/>
+              <a:rPr lang="en-ZA" sz="1300" b="1" i="0">
+                <a:solidFill>
+                  <a:srgbClr val="751F35"/>
                 </a:solidFill>
                 <a:latin typeface="Calibri"/>
                 <a:ea typeface="Calibri"/>
@@ -12399,9 +12399,9 @@
               </a:spcAft>
             </a:pPr>
             <a:r>
-              <a:rPr sz="1400" b="1" i="0">
-                <a:solidFill>
-                  <a:srgbClr val="0E4B48"/>
+              <a:rPr lang="en-ZA" sz="1400" b="1" i="0">
+                <a:solidFill>
+                  <a:srgbClr val="751F35"/>
                 </a:solidFill>
                 <a:latin typeface="Calibri"/>
                 <a:ea typeface="Calibri"/>
@@ -12471,7 +12471,7 @@
             </a:avLst>
           </a:prstGeom>
           <a:solidFill>
-            <a:srgbClr val="0E4B48"/>
+            <a:srgbClr val="751F35"/>
           </a:solidFill>
           <a:ln>
             <a:noFill/>
@@ -12504,9 +12504,9 @@
               </a:spcAft>
             </a:pPr>
             <a:r>
-              <a:rPr sz="1400" b="1" i="0">
-                <a:solidFill>
-                  <a:srgbClr val="E4F0EE"/>
+              <a:rPr lang="en-ZA" sz="1400" b="1" i="0">
+                <a:solidFill>
+                  <a:srgbClr val="F1E3E7"/>
                 </a:solidFill>
                 <a:latin typeface="Calibri"/>
                 <a:ea typeface="Calibri"/>
@@ -12607,7 +12607,7 @@
             <a:avLst/>
           </a:prstGeom>
           <a:solidFill>
-            <a:srgbClr val="0E4B48"/>
+            <a:srgbClr val="751F35"/>
           </a:solidFill>
           <a:ln>
             <a:noFill/>
@@ -12749,9 +12749,9 @@
               </a:spcAft>
             </a:pPr>
             <a:r>
-              <a:rPr sz="1300" b="1" i="0">
-                <a:solidFill>
-                  <a:srgbClr val="0E4B48"/>
+              <a:rPr lang="en-ZA" sz="1300" b="1" i="0">
+                <a:solidFill>
+                  <a:srgbClr val="751F35"/>
                 </a:solidFill>
                 <a:latin typeface="Calibri"/>
                 <a:ea typeface="Calibri"/>
@@ -12833,9 +12833,9 @@
               </a:spcAft>
             </a:pPr>
             <a:r>
-              <a:rPr sz="1600" b="1" i="0">
-                <a:solidFill>
-                  <a:srgbClr val="0E4B48"/>
+              <a:rPr lang="en-ZA" sz="1600" b="1" i="0">
+                <a:solidFill>
+                  <a:srgbClr val="751F35"/>
                 </a:solidFill>
                 <a:latin typeface="Calibri"/>
                 <a:ea typeface="Calibri"/>
@@ -13043,9 +13043,9 @@
               </a:spcAft>
             </a:pPr>
             <a:r>
-              <a:rPr sz="1600" b="1" i="0">
-                <a:solidFill>
-                  <a:srgbClr val="0E4B48"/>
+              <a:rPr lang="en-ZA" sz="1600" b="1" i="0">
+                <a:solidFill>
+                  <a:srgbClr val="751F35"/>
                 </a:solidFill>
                 <a:latin typeface="Calibri"/>
                 <a:ea typeface="Calibri"/>
@@ -13251,7 +13251,7 @@
             <a:avLst/>
           </a:prstGeom>
           <a:solidFill>
-            <a:srgbClr val="0E4B48"/>
+            <a:srgbClr val="751F35"/>
           </a:solidFill>
           <a:ln>
             <a:noFill/>
@@ -13393,9 +13393,9 @@
               </a:spcAft>
             </a:pPr>
             <a:r>
-              <a:rPr sz="1300" b="1" i="0">
-                <a:solidFill>
-                  <a:srgbClr val="0E4B48"/>
+              <a:rPr lang="en-ZA" sz="1300" b="1" i="0">
+                <a:solidFill>
+                  <a:srgbClr val="751F35"/>
                 </a:solidFill>
                 <a:latin typeface="Calibri"/>
                 <a:ea typeface="Calibri"/>
@@ -13509,7 +13509,7 @@
             <a:avLst/>
           </a:prstGeom>
           <a:solidFill>
-            <a:srgbClr val="0E4B48"/>
+            <a:srgbClr val="751F35"/>
           </a:solidFill>
           <a:ln>
             <a:noFill/>
@@ -13588,9 +13588,9 @@
               </a:spcAft>
             </a:pPr>
             <a:r>
-              <a:rPr sz="2600" b="1" i="0">
-                <a:solidFill>
-                  <a:srgbClr val="0E4B48"/>
+              <a:rPr lang="en-ZA" sz="2600" b="1" i="0">
+                <a:solidFill>
+                  <a:srgbClr val="751F35"/>
                 </a:solidFill>
                 <a:latin typeface="Calibri"/>
                 <a:ea typeface="Calibri"/>
@@ -13767,7 +13767,7 @@
             <a:avLst/>
           </a:prstGeom>
           <a:solidFill>
-            <a:srgbClr val="0E4B48"/>
+            <a:srgbClr val="751F35"/>
           </a:solidFill>
           <a:ln>
             <a:noFill/>
@@ -13846,9 +13846,9 @@
               </a:spcAft>
             </a:pPr>
             <a:r>
-              <a:rPr sz="2600" b="1" i="0">
-                <a:solidFill>
-                  <a:srgbClr val="0E4B48"/>
+              <a:rPr lang="en-ZA" sz="2600" b="1" i="0">
+                <a:solidFill>
+                  <a:srgbClr val="751F35"/>
                 </a:solidFill>
                 <a:latin typeface="Calibri"/>
                 <a:ea typeface="Calibri"/>
@@ -14025,7 +14025,7 @@
             <a:avLst/>
           </a:prstGeom>
           <a:solidFill>
-            <a:srgbClr val="0E4B48"/>
+            <a:srgbClr val="751F35"/>
           </a:solidFill>
           <a:ln>
             <a:noFill/>
@@ -14104,9 +14104,9 @@
               </a:spcAft>
             </a:pPr>
             <a:r>
-              <a:rPr sz="2600" b="1" i="0">
-                <a:solidFill>
-                  <a:srgbClr val="0E4B48"/>
+              <a:rPr lang="en-ZA" sz="2600" b="1" i="0">
+                <a:solidFill>
+                  <a:srgbClr val="751F35"/>
                 </a:solidFill>
                 <a:latin typeface="Calibri"/>
                 <a:ea typeface="Calibri"/>
@@ -14283,7 +14283,7 @@
             <a:avLst/>
           </a:prstGeom>
           <a:solidFill>
-            <a:srgbClr val="0E4B48"/>
+            <a:srgbClr val="751F35"/>
           </a:solidFill>
           <a:ln>
             <a:noFill/>
@@ -14362,9 +14362,9 @@
               </a:spcAft>
             </a:pPr>
             <a:r>
-              <a:rPr sz="2600" b="1" i="0">
-                <a:solidFill>
-                  <a:srgbClr val="0E4B48"/>
+              <a:rPr lang="en-ZA" sz="2600" b="1" i="0">
+                <a:solidFill>
+                  <a:srgbClr val="751F35"/>
                 </a:solidFill>
                 <a:latin typeface="Calibri"/>
                 <a:ea typeface="Calibri"/>
@@ -14528,7 +14528,7 @@
             <a:avLst/>
           </a:prstGeom>
           <a:solidFill>
-            <a:srgbClr val="0E4B48"/>
+            <a:srgbClr val="751F35"/>
           </a:solidFill>
           <a:ln>
             <a:noFill/>
@@ -14670,9 +14670,9 @@
               </a:spcAft>
             </a:pPr>
             <a:r>
-              <a:rPr sz="1300" b="1" i="0">
-                <a:solidFill>
-                  <a:srgbClr val="0E4B48"/>
+              <a:rPr lang="en-ZA" sz="1300" b="1" i="0">
+                <a:solidFill>
+                  <a:srgbClr val="751F35"/>
                 </a:solidFill>
                 <a:latin typeface="Calibri"/>
                 <a:ea typeface="Calibri"/>
@@ -14742,7 +14742,7 @@
             </a:avLst>
           </a:prstGeom>
           <a:solidFill>
-            <a:srgbClr val="E4F0EE"/>
+            <a:srgbClr val="F1E3E7"/>
           </a:solidFill>
           <a:ln>
             <a:noFill/>
@@ -14817,9 +14817,9 @@
               </a:spcAft>
             </a:pPr>
             <a:r>
-              <a:rPr sz="1600" b="1" i="0">
-                <a:solidFill>
-                  <a:srgbClr val="0E4B48"/>
+              <a:rPr lang="en-ZA" sz="1600" b="1" i="0">
+                <a:solidFill>
+                  <a:srgbClr val="751F35"/>
                 </a:solidFill>
                 <a:latin typeface="Calibri"/>
                 <a:ea typeface="Calibri"/>
@@ -14847,7 +14847,7 @@
             </a:avLst>
           </a:prstGeom>
           <a:solidFill>
-            <a:srgbClr val="E4F0EE"/>
+            <a:srgbClr val="F1E3E7"/>
           </a:solidFill>
           <a:ln>
             <a:noFill/>
@@ -14922,9 +14922,9 @@
               </a:spcAft>
             </a:pPr>
             <a:r>
-              <a:rPr sz="1600" b="1" i="0">
-                <a:solidFill>
-                  <a:srgbClr val="0E4B48"/>
+              <a:rPr lang="en-ZA" sz="1600" b="1" i="0">
+                <a:solidFill>
+                  <a:srgbClr val="751F35"/>
                 </a:solidFill>
                 <a:latin typeface="Calibri"/>
                 <a:ea typeface="Calibri"/>
@@ -14952,7 +14952,7 @@
             </a:avLst>
           </a:prstGeom>
           <a:solidFill>
-            <a:srgbClr val="E4F0EE"/>
+            <a:srgbClr val="F1E3E7"/>
           </a:solidFill>
           <a:ln>
             <a:noFill/>
@@ -15027,9 +15027,9 @@
               </a:spcAft>
             </a:pPr>
             <a:r>
-              <a:rPr sz="1600" b="1" i="0">
-                <a:solidFill>
-                  <a:srgbClr val="0E4B48"/>
+              <a:rPr lang="en-ZA" sz="1600" b="1" i="0">
+                <a:solidFill>
+                  <a:srgbClr val="751F35"/>
                 </a:solidFill>
                 <a:latin typeface="Calibri"/>
                 <a:ea typeface="Calibri"/>
@@ -15057,7 +15057,7 @@
             </a:avLst>
           </a:prstGeom>
           <a:solidFill>
-            <a:srgbClr val="E4F0EE"/>
+            <a:srgbClr val="F1E3E7"/>
           </a:solidFill>
           <a:ln>
             <a:noFill/>
@@ -15132,9 +15132,9 @@
               </a:spcAft>
             </a:pPr>
             <a:r>
-              <a:rPr sz="1600" b="1" i="0">
-                <a:solidFill>
-                  <a:srgbClr val="0E4B48"/>
+              <a:rPr lang="en-ZA" sz="1600" b="1" i="0">
+                <a:solidFill>
+                  <a:srgbClr val="751F35"/>
                 </a:solidFill>
                 <a:latin typeface="Calibri"/>
                 <a:ea typeface="Calibri"/>
@@ -15162,7 +15162,7 @@
             </a:avLst>
           </a:prstGeom>
           <a:solidFill>
-            <a:srgbClr val="0E4B48"/>
+            <a:srgbClr val="751F35"/>
           </a:solidFill>
           <a:ln>
             <a:noFill/>
@@ -15424,7 +15424,7 @@
             <a:avLst/>
           </a:prstGeom>
           <a:solidFill>
-            <a:srgbClr val="0E4B48"/>
+            <a:srgbClr val="751F35"/>
           </a:solidFill>
           <a:ln>
             <a:noFill/>
@@ -15566,9 +15566,9 @@
               </a:spcAft>
             </a:pPr>
             <a:r>
-              <a:rPr sz="1300" b="1" i="0">
-                <a:solidFill>
-                  <a:srgbClr val="0E4B48"/>
+              <a:rPr lang="en-ZA" sz="1300" b="1" i="0">
+                <a:solidFill>
+                  <a:srgbClr val="751F35"/>
                 </a:solidFill>
                 <a:latin typeface="Calibri"/>
                 <a:ea typeface="Calibri"/>
@@ -15638,7 +15638,7 @@
             </a:avLst>
           </a:prstGeom>
           <a:solidFill>
-            <a:srgbClr val="E4F0EE"/>
+            <a:srgbClr val="F1E3E7"/>
           </a:solidFill>
           <a:ln>
             <a:noFill/>
@@ -15713,9 +15713,9 @@
               </a:spcAft>
             </a:pPr>
             <a:r>
-              <a:rPr sz="1600" b="1" i="0">
-                <a:solidFill>
-                  <a:srgbClr val="0E4B48"/>
+              <a:rPr lang="en-ZA" sz="1600" b="1" i="0">
+                <a:solidFill>
+                  <a:srgbClr val="751F35"/>
                 </a:solidFill>
                 <a:latin typeface="Calibri"/>
                 <a:ea typeface="Calibri"/>
@@ -15743,7 +15743,7 @@
             </a:avLst>
           </a:prstGeom>
           <a:solidFill>
-            <a:srgbClr val="E4F0EE"/>
+            <a:srgbClr val="F1E3E7"/>
           </a:solidFill>
           <a:ln>
             <a:noFill/>
@@ -15818,9 +15818,9 @@
               </a:spcAft>
             </a:pPr>
             <a:r>
-              <a:rPr sz="1600" b="1" i="0">
-                <a:solidFill>
-                  <a:srgbClr val="0E4B48"/>
+              <a:rPr lang="en-ZA" sz="1600" b="1" i="0">
+                <a:solidFill>
+                  <a:srgbClr val="751F35"/>
                 </a:solidFill>
                 <a:latin typeface="Calibri"/>
                 <a:ea typeface="Calibri"/>
@@ -15848,7 +15848,7 @@
             </a:avLst>
           </a:prstGeom>
           <a:solidFill>
-            <a:srgbClr val="0E4B48"/>
+            <a:srgbClr val="751F35"/>
           </a:solidFill>
           <a:ln>
             <a:noFill/>
@@ -16110,7 +16110,7 @@
             <a:avLst/>
           </a:prstGeom>
           <a:solidFill>
-            <a:srgbClr val="0E4B48"/>
+            <a:srgbClr val="751F35"/>
           </a:solidFill>
           <a:ln>
             <a:noFill/>
@@ -16252,9 +16252,9 @@
               </a:spcAft>
             </a:pPr>
             <a:r>
-              <a:rPr sz="1300" b="1" i="0">
-                <a:solidFill>
-                  <a:srgbClr val="0E4B48"/>
+              <a:rPr lang="en-ZA" sz="1300" b="1" i="0">
+                <a:solidFill>
+                  <a:srgbClr val="751F35"/>
                 </a:solidFill>
                 <a:latin typeface="Calibri"/>
                 <a:ea typeface="Calibri"/>
@@ -16324,7 +16324,7 @@
             </a:avLst>
           </a:prstGeom>
           <a:solidFill>
-            <a:srgbClr val="E4F0EE"/>
+            <a:srgbClr val="F1E3E7"/>
           </a:solidFill>
           <a:ln>
             <a:noFill/>
@@ -16399,9 +16399,9 @@
               </a:spcAft>
             </a:pPr>
             <a:r>
-              <a:rPr sz="1600" b="1" i="0">
-                <a:solidFill>
-                  <a:srgbClr val="0E4B48"/>
+              <a:rPr lang="en-ZA" sz="1600" b="1" i="0">
+                <a:solidFill>
+                  <a:srgbClr val="751F35"/>
                 </a:solidFill>
                 <a:latin typeface="Calibri"/>
                 <a:ea typeface="Calibri"/>
@@ -16429,7 +16429,7 @@
             </a:avLst>
           </a:prstGeom>
           <a:solidFill>
-            <a:srgbClr val="E4F0EE"/>
+            <a:srgbClr val="F1E3E7"/>
           </a:solidFill>
           <a:ln>
             <a:noFill/>
@@ -16504,9 +16504,9 @@
               </a:spcAft>
             </a:pPr>
             <a:r>
-              <a:rPr sz="1600" b="1" i="0">
-                <a:solidFill>
-                  <a:srgbClr val="0E4B48"/>
+              <a:rPr lang="en-ZA" sz="1600" b="1" i="0">
+                <a:solidFill>
+                  <a:srgbClr val="751F35"/>
                 </a:solidFill>
                 <a:latin typeface="Calibri"/>
                 <a:ea typeface="Calibri"/>
@@ -16534,7 +16534,7 @@
             </a:avLst>
           </a:prstGeom>
           <a:solidFill>
-            <a:srgbClr val="E4F0EE"/>
+            <a:srgbClr val="F1E3E7"/>
           </a:solidFill>
           <a:ln>
             <a:noFill/>
@@ -16609,9 +16609,9 @@
               </a:spcAft>
             </a:pPr>
             <a:r>
-              <a:rPr sz="1600" b="1" i="0">
-                <a:solidFill>
-                  <a:srgbClr val="0E4B48"/>
+              <a:rPr lang="en-ZA" sz="1600" b="1" i="0">
+                <a:solidFill>
+                  <a:srgbClr val="751F35"/>
                 </a:solidFill>
                 <a:latin typeface="Calibri"/>
                 <a:ea typeface="Calibri"/>
@@ -16639,7 +16639,7 @@
             </a:avLst>
           </a:prstGeom>
           <a:solidFill>
-            <a:srgbClr val="0E4B48"/>
+            <a:srgbClr val="751F35"/>
           </a:solidFill>
           <a:ln>
             <a:noFill/>
@@ -16901,7 +16901,7 @@
             <a:avLst/>
           </a:prstGeom>
           <a:solidFill>
-            <a:srgbClr val="0E4B48"/>
+            <a:srgbClr val="751F35"/>
           </a:solidFill>
           <a:ln>
             <a:noFill/>
@@ -17043,9 +17043,9 @@
               </a:spcAft>
             </a:pPr>
             <a:r>
-              <a:rPr sz="1300" b="1" i="0">
-                <a:solidFill>
-                  <a:srgbClr val="0E4B48"/>
+              <a:rPr lang="en-ZA" sz="1300" b="1" i="0">
+                <a:solidFill>
+                  <a:srgbClr val="751F35"/>
                 </a:solidFill>
                 <a:latin typeface="Calibri"/>
                 <a:ea typeface="Calibri"/>
@@ -17115,7 +17115,7 @@
             </a:avLst>
           </a:prstGeom>
           <a:solidFill>
-            <a:srgbClr val="E4F0EE"/>
+            <a:srgbClr val="F1E3E7"/>
           </a:solidFill>
           <a:ln>
             <a:noFill/>
@@ -17190,9 +17190,9 @@
               </a:spcAft>
             </a:pPr>
             <a:r>
-              <a:rPr sz="1600" b="1" i="0">
-                <a:solidFill>
-                  <a:srgbClr val="0E4B48"/>
+              <a:rPr lang="en-ZA" sz="1600" b="1" i="0">
+                <a:solidFill>
+                  <a:srgbClr val="751F35"/>
                 </a:solidFill>
                 <a:latin typeface="Calibri"/>
                 <a:ea typeface="Calibri"/>
@@ -17220,7 +17220,7 @@
             </a:avLst>
           </a:prstGeom>
           <a:solidFill>
-            <a:srgbClr val="E4F0EE"/>
+            <a:srgbClr val="F1E3E7"/>
           </a:solidFill>
           <a:ln>
             <a:noFill/>
@@ -17295,9 +17295,9 @@
               </a:spcAft>
             </a:pPr>
             <a:r>
-              <a:rPr sz="1600" b="1" i="0">
-                <a:solidFill>
-                  <a:srgbClr val="0E4B48"/>
+              <a:rPr lang="en-ZA" sz="1600" b="1" i="0">
+                <a:solidFill>
+                  <a:srgbClr val="751F35"/>
                 </a:solidFill>
                 <a:latin typeface="Calibri"/>
                 <a:ea typeface="Calibri"/>
@@ -17325,7 +17325,7 @@
             </a:avLst>
           </a:prstGeom>
           <a:solidFill>
-            <a:srgbClr val="0E4B48"/>
+            <a:srgbClr val="751F35"/>
           </a:solidFill>
           <a:ln>
             <a:noFill/>
@@ -17465,9 +17465,9 @@
               </a:spcAft>
             </a:pPr>
             <a:r>
-              <a:rPr sz="2200" b="1" i="0">
-                <a:solidFill>
-                  <a:srgbClr val="0E4B48"/>
+              <a:rPr lang="en-ZA" sz="2200" b="1" i="0">
+                <a:solidFill>
+                  <a:srgbClr val="751F35"/>
                 </a:solidFill>
                 <a:latin typeface="Calibri"/>
                 <a:ea typeface="Calibri"/>
@@ -17551,9 +17551,9 @@
               </a:spcAft>
             </a:pPr>
             <a:r>
-              <a:rPr sz="2200" b="1" i="0">
-                <a:solidFill>
-                  <a:srgbClr val="0E4B48"/>
+              <a:rPr lang="en-ZA" sz="2200" b="1" i="0">
+                <a:solidFill>
+                  <a:srgbClr val="751F35"/>
                 </a:solidFill>
                 <a:latin typeface="Calibri"/>
                 <a:ea typeface="Calibri"/>
@@ -17637,9 +17637,9 @@
               </a:spcAft>
             </a:pPr>
             <a:r>
-              <a:rPr sz="2200" b="1" i="0">
-                <a:solidFill>
-                  <a:srgbClr val="0E4B48"/>
+              <a:rPr lang="en-ZA" sz="2200" b="1" i="0">
+                <a:solidFill>
+                  <a:srgbClr val="751F35"/>
                 </a:solidFill>
                 <a:latin typeface="Calibri"/>
                 <a:ea typeface="Calibri"/>
@@ -17719,7 +17719,7 @@
             <a:avLst/>
           </a:prstGeom>
           <a:solidFill>
-            <a:srgbClr val="0E4B48"/>
+            <a:srgbClr val="751F35"/>
           </a:solidFill>
           <a:ln>
             <a:noFill/>
@@ -17861,9 +17861,9 @@
               </a:spcAft>
             </a:pPr>
             <a:r>
-              <a:rPr sz="1300" b="1" i="0">
-                <a:solidFill>
-                  <a:srgbClr val="0E4B48"/>
+              <a:rPr lang="en-ZA" sz="1300" b="1" i="0">
+                <a:solidFill>
+                  <a:srgbClr val="751F35"/>
                 </a:solidFill>
                 <a:latin typeface="Calibri"/>
                 <a:ea typeface="Calibri"/>
@@ -17968,9 +17968,9 @@
               </a:spcAft>
             </a:pPr>
             <a:r>
-              <a:rPr sz="1400" b="1" i="0">
-                <a:solidFill>
-                  <a:srgbClr val="0E4B48"/>
+              <a:rPr lang="en-ZA" sz="1400" b="1" i="0">
+                <a:solidFill>
+                  <a:srgbClr val="751F35"/>
                 </a:solidFill>
                 <a:latin typeface="Calibri"/>
                 <a:ea typeface="Calibri"/>
@@ -18075,9 +18075,9 @@
               </a:spcAft>
             </a:pPr>
             <a:r>
-              <a:rPr sz="1400" b="1" i="0">
-                <a:solidFill>
-                  <a:srgbClr val="0E4B48"/>
+              <a:rPr lang="en-ZA" sz="1400" b="1" i="0">
+                <a:solidFill>
+                  <a:srgbClr val="751F35"/>
                 </a:solidFill>
                 <a:latin typeface="Calibri"/>
                 <a:ea typeface="Calibri"/>
@@ -18304,7 +18304,7 @@
             <a:avLst/>
           </a:prstGeom>
           <a:solidFill>
-            <a:srgbClr val="0E4B48"/>
+            <a:srgbClr val="751F35"/>
           </a:solidFill>
           <a:ln>
             <a:noFill/>
@@ -18355,7 +18355,7 @@
             <a:avLst/>
           </a:prstGeom>
           <a:solidFill>
-            <a:srgbClr val="0E4B48"/>
+            <a:srgbClr val="751F35"/>
           </a:solidFill>
           <a:ln>
             <a:noFill/>
@@ -18416,7 +18416,7 @@
             <a:avLst/>
           </a:prstGeom>
           <a:solidFill>
-            <a:srgbClr val="0E4B48"/>
+            <a:srgbClr val="751F35"/>
           </a:solidFill>
           <a:ln>
             <a:noFill/>
@@ -18477,7 +18477,7 @@
             <a:avLst/>
           </a:prstGeom>
           <a:solidFill>
-            <a:srgbClr val="0E4B48"/>
+            <a:srgbClr val="751F35"/>
           </a:solidFill>
           <a:ln>
             <a:noFill/>
@@ -18538,7 +18538,7 @@
             <a:avLst/>
           </a:prstGeom>
           <a:solidFill>
-            <a:srgbClr val="0E4B48"/>
+            <a:srgbClr val="751F35"/>
           </a:solidFill>
           <a:ln>
             <a:noFill/>

</xml_diff>